<commit_message>
Update PowerPoint for song #184 in FUBC - Українські
</commit_message>
<xml_diff>
--- a/fubc-ua/184-Я співаю, як Спаситель (Пісні Спасенних №182).pptx
+++ b/fubc-ua/184-Я співаю, як Спаситель (Пісні Спасенних №182).pptx
@@ -1535,23 +1535,6 @@
             </a:r>
             <a:endParaRPr lang="en-US" sz="5200" dirty="0"/>
           </a:p>
-          <a:p>
-            <a:pPr algn="ctr" indent="0" marL="0">
-              <a:buNone/>
-            </a:pPr>
-            <a:r>
-              <a:rPr lang="en-US" sz="5200" b="1" dirty="0">
-                <a:solidFill>
-                  <a:srgbClr val="FFFFFF"/>
-                </a:solidFill>
-                <a:latin typeface="Arial" pitchFamily="34" charset="0"/>
-                <a:ea typeface="Arial" pitchFamily="34" charset="-122"/>
-                <a:cs typeface="Arial" pitchFamily="34" charset="-120"/>
-              </a:rPr>
-              <a:t>(Пісні Спасенних №182)</a:t>
-            </a:r>
-            <a:endParaRPr lang="en-US" sz="5200" dirty="0"/>
-          </a:p>
         </p:txBody>
       </p:sp>
     </p:spTree>
@@ -1733,7 +1716,7 @@
               <a:buNone/>
             </a:pPr>
             <a:r>
-              <a:rPr lang="en-US" sz="5000" b="1" i="1" dirty="0">
+              <a:rPr lang="en-US" sz="5200" b="1" i="1" dirty="0">
                 <a:solidFill>
                   <a:srgbClr val="FFFFFF"/>
                 </a:solidFill>
@@ -1743,14 +1726,14 @@
               </a:rPr>
               <a:t>Пісня ллється про Ісуса!</a:t>
             </a:r>
-            <a:endParaRPr lang="en-US" sz="5000" dirty="0"/>
+            <a:endParaRPr lang="en-US" sz="5200" dirty="0"/>
           </a:p>
           <a:p>
             <a:pPr algn="ctr" indent="0" marL="0">
               <a:buNone/>
             </a:pPr>
             <a:r>
-              <a:rPr lang="en-US" sz="5000" b="1" i="1" dirty="0">
+              <a:rPr lang="en-US" sz="5200" b="1" i="1" dirty="0">
                 <a:solidFill>
                   <a:srgbClr val="FFFFFF"/>
                 </a:solidFill>
@@ -1760,14 +1743,14 @@
               </a:rPr>
               <a:t>Він мої гріхи простив,</a:t>
             </a:r>
-            <a:endParaRPr lang="en-US" sz="5000" dirty="0"/>
+            <a:endParaRPr lang="en-US" sz="5200" dirty="0"/>
           </a:p>
           <a:p>
             <a:pPr algn="ctr" indent="0" marL="0">
               <a:buNone/>
             </a:pPr>
             <a:r>
-              <a:rPr lang="en-US" sz="5000" b="1" i="1" dirty="0">
+              <a:rPr lang="en-US" sz="5200" b="1" i="1" dirty="0">
                 <a:solidFill>
                   <a:srgbClr val="FFFFFF"/>
                 </a:solidFill>
@@ -1777,14 +1760,14 @@
               </a:rPr>
               <a:t>кров пролив Свою святую</a:t>
             </a:r>
-            <a:endParaRPr lang="en-US" sz="5000" dirty="0"/>
+            <a:endParaRPr lang="en-US" sz="5200" dirty="0"/>
           </a:p>
           <a:p>
             <a:pPr algn="ctr" indent="0" marL="0">
               <a:buNone/>
             </a:pPr>
             <a:r>
-              <a:rPr lang="en-US" sz="5000" b="1" i="1" dirty="0">
+              <a:rPr lang="en-US" sz="5200" b="1" i="1" dirty="0">
                 <a:solidFill>
                   <a:srgbClr val="FFFFFF"/>
                 </a:solidFill>
@@ -1792,9 +1775,9 @@
                 <a:ea typeface="Arial" pitchFamily="34" charset="-122"/>
                 <a:cs typeface="Arial" pitchFamily="34" charset="-120"/>
               </a:rPr>
-              <a:t>і від смерті відкупив (Він відкупив).</a:t>
-            </a:r>
-            <a:endParaRPr lang="en-US" sz="5000" dirty="0"/>
+              <a:t>і від смерті відкупив.</a:t>
+            </a:r>
+            <a:endParaRPr lang="en-US" sz="5200" dirty="0"/>
           </a:p>
         </p:txBody>
       </p:sp>
@@ -1977,7 +1960,7 @@
               <a:buNone/>
             </a:pPr>
             <a:r>
-              <a:rPr lang="en-US" sz="5000" b="1" i="1" dirty="0">
+              <a:rPr lang="en-US" sz="5200" b="1" i="1" dirty="0">
                 <a:solidFill>
                   <a:srgbClr val="FFFFFF"/>
                 </a:solidFill>
@@ -1987,14 +1970,14 @@
               </a:rPr>
               <a:t>Пісня ллється про Ісуса!</a:t>
             </a:r>
-            <a:endParaRPr lang="en-US" sz="5000" dirty="0"/>
+            <a:endParaRPr lang="en-US" sz="5200" dirty="0"/>
           </a:p>
           <a:p>
             <a:pPr algn="ctr" indent="0" marL="0">
               <a:buNone/>
             </a:pPr>
             <a:r>
-              <a:rPr lang="en-US" sz="5000" b="1" i="1" dirty="0">
+              <a:rPr lang="en-US" sz="5200" b="1" i="1" dirty="0">
                 <a:solidFill>
                   <a:srgbClr val="FFFFFF"/>
                 </a:solidFill>
@@ -2004,14 +1987,14 @@
               </a:rPr>
               <a:t>Він мої гріхи простив,</a:t>
             </a:r>
-            <a:endParaRPr lang="en-US" sz="5000" dirty="0"/>
+            <a:endParaRPr lang="en-US" sz="5200" dirty="0"/>
           </a:p>
           <a:p>
             <a:pPr algn="ctr" indent="0" marL="0">
               <a:buNone/>
             </a:pPr>
             <a:r>
-              <a:rPr lang="en-US" sz="5000" b="1" i="1" dirty="0">
+              <a:rPr lang="en-US" sz="5200" b="1" i="1" dirty="0">
                 <a:solidFill>
                   <a:srgbClr val="FFFFFF"/>
                 </a:solidFill>
@@ -2021,14 +2004,14 @@
               </a:rPr>
               <a:t>кров пролив Свою святую</a:t>
             </a:r>
-            <a:endParaRPr lang="en-US" sz="5000" dirty="0"/>
+            <a:endParaRPr lang="en-US" sz="5200" dirty="0"/>
           </a:p>
           <a:p>
             <a:pPr algn="ctr" indent="0" marL="0">
               <a:buNone/>
             </a:pPr>
             <a:r>
-              <a:rPr lang="en-US" sz="5000" b="1" i="1" dirty="0">
+              <a:rPr lang="en-US" sz="5200" b="1" i="1" dirty="0">
                 <a:solidFill>
                   <a:srgbClr val="FFFFFF"/>
                 </a:solidFill>
@@ -2036,9 +2019,9 @@
                 <a:ea typeface="Arial" pitchFamily="34" charset="-122"/>
                 <a:cs typeface="Arial" pitchFamily="34" charset="-120"/>
               </a:rPr>
-              <a:t>і від смерті відкупив (Він відкупив).</a:t>
-            </a:r>
-            <a:endParaRPr lang="en-US" sz="5000" dirty="0"/>
+              <a:t>і від смерті відкупив.</a:t>
+            </a:r>
+            <a:endParaRPr lang="en-US" sz="5200" dirty="0"/>
           </a:p>
         </p:txBody>
       </p:sp>
@@ -2221,7 +2204,7 @@
               <a:buNone/>
             </a:pPr>
             <a:r>
-              <a:rPr lang="en-US" sz="5000" b="1" i="1" dirty="0">
+              <a:rPr lang="en-US" sz="5200" b="1" i="1" dirty="0">
                 <a:solidFill>
                   <a:srgbClr val="FFFFFF"/>
                 </a:solidFill>
@@ -2231,14 +2214,14 @@
               </a:rPr>
               <a:t>Пісня ллється про Ісуса!</a:t>
             </a:r>
-            <a:endParaRPr lang="en-US" sz="5000" dirty="0"/>
+            <a:endParaRPr lang="en-US" sz="5200" dirty="0"/>
           </a:p>
           <a:p>
             <a:pPr algn="ctr" indent="0" marL="0">
               <a:buNone/>
             </a:pPr>
             <a:r>
-              <a:rPr lang="en-US" sz="5000" b="1" i="1" dirty="0">
+              <a:rPr lang="en-US" sz="5200" b="1" i="1" dirty="0">
                 <a:solidFill>
                   <a:srgbClr val="FFFFFF"/>
                 </a:solidFill>
@@ -2248,14 +2231,14 @@
               </a:rPr>
               <a:t>Він мої гріхи простив,</a:t>
             </a:r>
-            <a:endParaRPr lang="en-US" sz="5000" dirty="0"/>
+            <a:endParaRPr lang="en-US" sz="5200" dirty="0"/>
           </a:p>
           <a:p>
             <a:pPr algn="ctr" indent="0" marL="0">
               <a:buNone/>
             </a:pPr>
             <a:r>
-              <a:rPr lang="en-US" sz="5000" b="1" i="1" dirty="0">
+              <a:rPr lang="en-US" sz="5200" b="1" i="1" dirty="0">
                 <a:solidFill>
                   <a:srgbClr val="FFFFFF"/>
                 </a:solidFill>
@@ -2265,14 +2248,14 @@
               </a:rPr>
               <a:t>кров пролив Свою святую</a:t>
             </a:r>
-            <a:endParaRPr lang="en-US" sz="5000" dirty="0"/>
+            <a:endParaRPr lang="en-US" sz="5200" dirty="0"/>
           </a:p>
           <a:p>
             <a:pPr algn="ctr" indent="0" marL="0">
               <a:buNone/>
             </a:pPr>
             <a:r>
-              <a:rPr lang="en-US" sz="5000" b="1" i="1" dirty="0">
+              <a:rPr lang="en-US" sz="5200" b="1" i="1" dirty="0">
                 <a:solidFill>
                   <a:srgbClr val="FFFFFF"/>
                 </a:solidFill>
@@ -2280,9 +2263,9 @@
                 <a:ea typeface="Arial" pitchFamily="34" charset="-122"/>
                 <a:cs typeface="Arial" pitchFamily="34" charset="-120"/>
               </a:rPr>
-              <a:t>і від смерті відкупив (Він відкупив).</a:t>
-            </a:r>
-            <a:endParaRPr lang="en-US" sz="5000" dirty="0"/>
+              <a:t>і від смерті відкупив.</a:t>
+            </a:r>
+            <a:endParaRPr lang="en-US" sz="5200" dirty="0"/>
           </a:p>
         </p:txBody>
       </p:sp>

</xml_diff>